<commit_message>
Fix completion report PDF layout
</commit_message>
<xml_diff>
--- a/deliverables/ReliefCheck_제24회_임베디드SW경진대회_개발완료보고서.pptx
+++ b/deliverables/ReliefCheck_제24회_임베디드SW경진대회_개발완료보고서.pptx
@@ -2,33 +2,33 @@
 <file path=ppt/presentation.xml><?xml version="1.0" encoding="utf-8"?>
 <p:presentation xmlns:p="http://schemas.openxmlformats.org/presentationml/2006/main">
   <p:sldMasterIdLst>
-    <p:sldMasterId xmlns:r="http://schemas.openxmlformats.org/officeDocument/2006/relationships" id="2147483648" r:id="R572df1a33e894c0f"/>
+    <p:sldMasterId xmlns:r="http://schemas.openxmlformats.org/officeDocument/2006/relationships" id="2147483648" r:id="R3d3bf894af524e24"/>
   </p:sldMasterIdLst>
   <p:notesMasterIdLst>
-    <p:notesMasterId xmlns:r="http://schemas.openxmlformats.org/officeDocument/2006/relationships" r:id="Rffd6b362e70e4ade"/>
+    <p:notesMasterId xmlns:r="http://schemas.openxmlformats.org/officeDocument/2006/relationships" r:id="R044ddea56fb34dc8"/>
   </p:notesMasterIdLst>
   <p:sldIdLst>
-    <p:sldId xmlns:r="http://schemas.openxmlformats.org/officeDocument/2006/relationships" id="256" r:id="R67b5b45cbc4947cf"/>
-    <p:sldId xmlns:r="http://schemas.openxmlformats.org/officeDocument/2006/relationships" id="257" r:id="R5d7c7e4f879845e2"/>
-    <p:sldId xmlns:r="http://schemas.openxmlformats.org/officeDocument/2006/relationships" id="258" r:id="R399a7f2cc73342b1"/>
-    <p:sldId xmlns:r="http://schemas.openxmlformats.org/officeDocument/2006/relationships" id="259" r:id="R6926581cd8854f31"/>
-    <p:sldId xmlns:r="http://schemas.openxmlformats.org/officeDocument/2006/relationships" id="260" r:id="R994e235f5ae64574"/>
-    <p:sldId xmlns:r="http://schemas.openxmlformats.org/officeDocument/2006/relationships" id="261" r:id="Rdd1bd30257d34b7b"/>
-    <p:sldId xmlns:r="http://schemas.openxmlformats.org/officeDocument/2006/relationships" id="262" r:id="R3144f79c08ce45af"/>
-    <p:sldId xmlns:r="http://schemas.openxmlformats.org/officeDocument/2006/relationships" id="263" r:id="R7a41ee4c86214af0"/>
-    <p:sldId xmlns:r="http://schemas.openxmlformats.org/officeDocument/2006/relationships" id="264" r:id="R7a084e9792f54659"/>
-    <p:sldId xmlns:r="http://schemas.openxmlformats.org/officeDocument/2006/relationships" id="265" r:id="R063eb0ec09524167"/>
-    <p:sldId xmlns:r="http://schemas.openxmlformats.org/officeDocument/2006/relationships" id="266" r:id="R9e30f93ab8b64b55"/>
-    <p:sldId xmlns:r="http://schemas.openxmlformats.org/officeDocument/2006/relationships" id="267" r:id="R28ad99462b6848f7"/>
-    <p:sldId xmlns:r="http://schemas.openxmlformats.org/officeDocument/2006/relationships" id="268" r:id="R12da66d464374b9a"/>
-    <p:sldId xmlns:r="http://schemas.openxmlformats.org/officeDocument/2006/relationships" id="269" r:id="Rafc593e46ec640d4"/>
-    <p:sldId xmlns:r="http://schemas.openxmlformats.org/officeDocument/2006/relationships" id="270" r:id="R8838e5e72c7540ba"/>
-    <p:sldId xmlns:r="http://schemas.openxmlformats.org/officeDocument/2006/relationships" id="271" r:id="Rdcff0dad7eba4dde"/>
-    <p:sldId xmlns:r="http://schemas.openxmlformats.org/officeDocument/2006/relationships" id="272" r:id="Rbe9a8cd45c314009"/>
-    <p:sldId xmlns:r="http://schemas.openxmlformats.org/officeDocument/2006/relationships" id="273" r:id="R6ce07f61606a4d1f"/>
-    <p:sldId xmlns:r="http://schemas.openxmlformats.org/officeDocument/2006/relationships" id="274" r:id="R659f2ce17ac0462b"/>
-    <p:sldId xmlns:r="http://schemas.openxmlformats.org/officeDocument/2006/relationships" id="275" r:id="R52fad8fee6414e4e"/>
-    <p:sldId xmlns:r="http://schemas.openxmlformats.org/officeDocument/2006/relationships" id="276" r:id="R92b58a822ddb4cce"/>
+    <p:sldId xmlns:r="http://schemas.openxmlformats.org/officeDocument/2006/relationships" id="256" r:id="Rb4d7c115d4784fbc"/>
+    <p:sldId xmlns:r="http://schemas.openxmlformats.org/officeDocument/2006/relationships" id="257" r:id="R256fc2b6184d4ad6"/>
+    <p:sldId xmlns:r="http://schemas.openxmlformats.org/officeDocument/2006/relationships" id="258" r:id="Rf01186aa15d641bf"/>
+    <p:sldId xmlns:r="http://schemas.openxmlformats.org/officeDocument/2006/relationships" id="259" r:id="Rdb7bdd4b10374711"/>
+    <p:sldId xmlns:r="http://schemas.openxmlformats.org/officeDocument/2006/relationships" id="260" r:id="R1c84576f9c59429a"/>
+    <p:sldId xmlns:r="http://schemas.openxmlformats.org/officeDocument/2006/relationships" id="261" r:id="R36c1df8f646243da"/>
+    <p:sldId xmlns:r="http://schemas.openxmlformats.org/officeDocument/2006/relationships" id="262" r:id="R664af0ee87b24b35"/>
+    <p:sldId xmlns:r="http://schemas.openxmlformats.org/officeDocument/2006/relationships" id="263" r:id="R6957f068894040cf"/>
+    <p:sldId xmlns:r="http://schemas.openxmlformats.org/officeDocument/2006/relationships" id="264" r:id="R9080e51320a2434d"/>
+    <p:sldId xmlns:r="http://schemas.openxmlformats.org/officeDocument/2006/relationships" id="265" r:id="Ra398f82b6061407a"/>
+    <p:sldId xmlns:r="http://schemas.openxmlformats.org/officeDocument/2006/relationships" id="266" r:id="Rb3b52c83a4c14ffd"/>
+    <p:sldId xmlns:r="http://schemas.openxmlformats.org/officeDocument/2006/relationships" id="267" r:id="R91cc2f409e8746cc"/>
+    <p:sldId xmlns:r="http://schemas.openxmlformats.org/officeDocument/2006/relationships" id="268" r:id="Rfb3943e517a946cd"/>
+    <p:sldId xmlns:r="http://schemas.openxmlformats.org/officeDocument/2006/relationships" id="269" r:id="Rca6e6a8fe7e34712"/>
+    <p:sldId xmlns:r="http://schemas.openxmlformats.org/officeDocument/2006/relationships" id="270" r:id="Rca74e9725b2b49d1"/>
+    <p:sldId xmlns:r="http://schemas.openxmlformats.org/officeDocument/2006/relationships" id="271" r:id="R5cc8f3933fc947e7"/>
+    <p:sldId xmlns:r="http://schemas.openxmlformats.org/officeDocument/2006/relationships" id="272" r:id="R164ba456881f4bc0"/>
+    <p:sldId xmlns:r="http://schemas.openxmlformats.org/officeDocument/2006/relationships" id="273" r:id="R908f1e153daf40e2"/>
+    <p:sldId xmlns:r="http://schemas.openxmlformats.org/officeDocument/2006/relationships" id="274" r:id="Ra257c7dffc024dd5"/>
+    <p:sldId xmlns:r="http://schemas.openxmlformats.org/officeDocument/2006/relationships" id="275" r:id="R4696b5a7bb9641a7"/>
+    <p:sldId xmlns:r="http://schemas.openxmlformats.org/officeDocument/2006/relationships" id="276" r:id="Rd3150484af114c35"/>
   </p:sldIdLst>
   <p:sldSz cx="12192000" cy="6858000"/>
   <p:notesSz cx="6858000" cy="9144000"/>
@@ -2035,7 +2035,7 @@
   </p:cSld>
   <p:clrMap bg1="lt1" tx1="dk1" bg2="lt2" tx2="dk2" accent1="accent1" accent2="accent2" accent3="accent3" accent4="accent4" accent5="accent5" accent6="accent6" hlink="hlink" folHlink="folHlink"/>
   <p:sldLayoutIdLst>
-    <p:sldLayoutId xmlns:r="http://schemas.openxmlformats.org/officeDocument/2006/relationships" id="2147483649" r:id="R2fc28827ab254e31"/>
+    <p:sldLayoutId xmlns:r="http://schemas.openxmlformats.org/officeDocument/2006/relationships" id="2147483649" r:id="R8271fe70686e4c94"/>
   </p:sldLayoutIdLst>
   <p:txStyles>
     <p:titleStyle>
@@ -2583,7 +2583,7 @@
           <p:nvPr/>
         </p:nvPicPr>
         <p:blipFill>
-          <a:blip xmlns:r="http://schemas.openxmlformats.org/officeDocument/2006/relationships" xmlns:a="http://schemas.openxmlformats.org/drawingml/2006/main" r:embed="R693f261d400548b3"/>
+          <a:blip xmlns:r="http://schemas.openxmlformats.org/officeDocument/2006/relationships" xmlns:a="http://schemas.openxmlformats.org/drawingml/2006/main" r:embed="Rf430a295c274441b"/>
           <a:srcRect xmlns:a="http://schemas.openxmlformats.org/drawingml/2006/main" l="0" t="0" r="0" b="0"/>
           <a:stretch xmlns:a="http://schemas.openxmlformats.org/drawingml/2006/main">
             <a:fillRect l="0" t="0" r="0" b="0"/>
@@ -2602,7 +2602,7 @@
     </p:spTree>
     <p:extLst>
       <p:ext uri="{BB962C8B-B14F-4D97-AF65-F5344CB8AC3E}">
-        <p14:creationId xmlns:p14="http://schemas.microsoft.com/office/powerpoint/2010/main" val="1656321963"/>
+        <p14:creationId xmlns:p14="http://schemas.microsoft.com/office/powerpoint/2010/main" val="1500604775"/>
       </p:ext>
     </p:extLst>
   </p:cSld>
@@ -2630,7 +2630,7 @@
           <p:nvPr/>
         </p:nvPicPr>
         <p:blipFill>
-          <a:blip xmlns:r="http://schemas.openxmlformats.org/officeDocument/2006/relationships" xmlns:a="http://schemas.openxmlformats.org/drawingml/2006/main" r:embed="R33e8d0a673984e96"/>
+          <a:blip xmlns:r="http://schemas.openxmlformats.org/officeDocument/2006/relationships" xmlns:a="http://schemas.openxmlformats.org/drawingml/2006/main" r:embed="Rbf3f738122264c4a"/>
           <a:srcRect xmlns:a="http://schemas.openxmlformats.org/drawingml/2006/main" l="0" t="0" r="0" b="0"/>
           <a:stretch xmlns:a="http://schemas.openxmlformats.org/drawingml/2006/main">
             <a:fillRect l="0" t="0" r="0" b="0"/>
@@ -2649,7 +2649,7 @@
     </p:spTree>
     <p:extLst>
       <p:ext uri="{BB962C8B-B14F-4D97-AF65-F5344CB8AC3E}">
-        <p14:creationId xmlns:p14="http://schemas.microsoft.com/office/powerpoint/2010/main" val="1885124985"/>
+        <p14:creationId xmlns:p14="http://schemas.microsoft.com/office/powerpoint/2010/main" val="1805567232"/>
       </p:ext>
     </p:extLst>
   </p:cSld>
@@ -2677,7 +2677,7 @@
           <p:nvPr/>
         </p:nvPicPr>
         <p:blipFill>
-          <a:blip xmlns:r="http://schemas.openxmlformats.org/officeDocument/2006/relationships" xmlns:a="http://schemas.openxmlformats.org/drawingml/2006/main" r:embed="R0edc47c108534bca"/>
+          <a:blip xmlns:r="http://schemas.openxmlformats.org/officeDocument/2006/relationships" xmlns:a="http://schemas.openxmlformats.org/drawingml/2006/main" r:embed="Rd0a962238ed04ed6"/>
           <a:srcRect xmlns:a="http://schemas.openxmlformats.org/drawingml/2006/main" l="0" t="0" r="0" b="0"/>
           <a:stretch xmlns:a="http://schemas.openxmlformats.org/drawingml/2006/main">
             <a:fillRect l="0" t="0" r="0" b="0"/>
@@ -2696,7 +2696,7 @@
     </p:spTree>
     <p:extLst>
       <p:ext uri="{BB962C8B-B14F-4D97-AF65-F5344CB8AC3E}">
-        <p14:creationId xmlns:p14="http://schemas.microsoft.com/office/powerpoint/2010/main" val="392071992"/>
+        <p14:creationId xmlns:p14="http://schemas.microsoft.com/office/powerpoint/2010/main" val="1301543655"/>
       </p:ext>
     </p:extLst>
   </p:cSld>
@@ -2724,7 +2724,7 @@
           <p:nvPr/>
         </p:nvPicPr>
         <p:blipFill>
-          <a:blip xmlns:r="http://schemas.openxmlformats.org/officeDocument/2006/relationships" xmlns:a="http://schemas.openxmlformats.org/drawingml/2006/main" r:embed="R6005415671914395"/>
+          <a:blip xmlns:r="http://schemas.openxmlformats.org/officeDocument/2006/relationships" xmlns:a="http://schemas.openxmlformats.org/drawingml/2006/main" r:embed="R7cc9d074e210430a"/>
           <a:srcRect xmlns:a="http://schemas.openxmlformats.org/drawingml/2006/main" l="0" t="0" r="0" b="0"/>
           <a:stretch xmlns:a="http://schemas.openxmlformats.org/drawingml/2006/main">
             <a:fillRect l="0" t="0" r="0" b="0"/>
@@ -2743,7 +2743,7 @@
     </p:spTree>
     <p:extLst>
       <p:ext uri="{BB962C8B-B14F-4D97-AF65-F5344CB8AC3E}">
-        <p14:creationId xmlns:p14="http://schemas.microsoft.com/office/powerpoint/2010/main" val="1012195254"/>
+        <p14:creationId xmlns:p14="http://schemas.microsoft.com/office/powerpoint/2010/main" val="1758107292"/>
       </p:ext>
     </p:extLst>
   </p:cSld>
@@ -2771,7 +2771,7 @@
           <p:nvPr/>
         </p:nvPicPr>
         <p:blipFill>
-          <a:blip xmlns:r="http://schemas.openxmlformats.org/officeDocument/2006/relationships" xmlns:a="http://schemas.openxmlformats.org/drawingml/2006/main" r:embed="R01866010762a494f"/>
+          <a:blip xmlns:r="http://schemas.openxmlformats.org/officeDocument/2006/relationships" xmlns:a="http://schemas.openxmlformats.org/drawingml/2006/main" r:embed="R20b6b34c50a74565"/>
           <a:srcRect xmlns:a="http://schemas.openxmlformats.org/drawingml/2006/main" l="0" t="0" r="0" b="0"/>
           <a:stretch xmlns:a="http://schemas.openxmlformats.org/drawingml/2006/main">
             <a:fillRect l="0" t="0" r="0" b="0"/>
@@ -2790,7 +2790,7 @@
     </p:spTree>
     <p:extLst>
       <p:ext uri="{BB962C8B-B14F-4D97-AF65-F5344CB8AC3E}">
-        <p14:creationId xmlns:p14="http://schemas.microsoft.com/office/powerpoint/2010/main" val="1121120211"/>
+        <p14:creationId xmlns:p14="http://schemas.microsoft.com/office/powerpoint/2010/main" val="963845687"/>
       </p:ext>
     </p:extLst>
   </p:cSld>
@@ -2818,7 +2818,7 @@
           <p:nvPr/>
         </p:nvPicPr>
         <p:blipFill>
-          <a:blip xmlns:r="http://schemas.openxmlformats.org/officeDocument/2006/relationships" xmlns:a="http://schemas.openxmlformats.org/drawingml/2006/main" r:embed="R678707bff4bd4006"/>
+          <a:blip xmlns:r="http://schemas.openxmlformats.org/officeDocument/2006/relationships" xmlns:a="http://schemas.openxmlformats.org/drawingml/2006/main" r:embed="Re44566baba304998"/>
           <a:srcRect xmlns:a="http://schemas.openxmlformats.org/drawingml/2006/main" l="0" t="0" r="0" b="0"/>
           <a:stretch xmlns:a="http://schemas.openxmlformats.org/drawingml/2006/main">
             <a:fillRect l="0" t="0" r="0" b="0"/>
@@ -2837,7 +2837,7 @@
     </p:spTree>
     <p:extLst>
       <p:ext uri="{BB962C8B-B14F-4D97-AF65-F5344CB8AC3E}">
-        <p14:creationId xmlns:p14="http://schemas.microsoft.com/office/powerpoint/2010/main" val="517353408"/>
+        <p14:creationId xmlns:p14="http://schemas.microsoft.com/office/powerpoint/2010/main" val="782017789"/>
       </p:ext>
     </p:extLst>
   </p:cSld>
@@ -2865,7 +2865,7 @@
           <p:nvPr/>
         </p:nvPicPr>
         <p:blipFill>
-          <a:blip xmlns:r="http://schemas.openxmlformats.org/officeDocument/2006/relationships" xmlns:a="http://schemas.openxmlformats.org/drawingml/2006/main" r:embed="Rce2367a7a6ca4963"/>
+          <a:blip xmlns:r="http://schemas.openxmlformats.org/officeDocument/2006/relationships" xmlns:a="http://schemas.openxmlformats.org/drawingml/2006/main" r:embed="R10a41705ca294074"/>
           <a:srcRect xmlns:a="http://schemas.openxmlformats.org/drawingml/2006/main" l="0" t="0" r="0" b="0"/>
           <a:stretch xmlns:a="http://schemas.openxmlformats.org/drawingml/2006/main">
             <a:fillRect l="0" t="0" r="0" b="0"/>
@@ -2884,7 +2884,7 @@
     </p:spTree>
     <p:extLst>
       <p:ext uri="{BB962C8B-B14F-4D97-AF65-F5344CB8AC3E}">
-        <p14:creationId xmlns:p14="http://schemas.microsoft.com/office/powerpoint/2010/main" val="1638121594"/>
+        <p14:creationId xmlns:p14="http://schemas.microsoft.com/office/powerpoint/2010/main" val="807849807"/>
       </p:ext>
     </p:extLst>
   </p:cSld>
@@ -2912,7 +2912,7 @@
           <p:nvPr/>
         </p:nvPicPr>
         <p:blipFill>
-          <a:blip xmlns:r="http://schemas.openxmlformats.org/officeDocument/2006/relationships" xmlns:a="http://schemas.openxmlformats.org/drawingml/2006/main" r:embed="R028a16d82dd94698"/>
+          <a:blip xmlns:r="http://schemas.openxmlformats.org/officeDocument/2006/relationships" xmlns:a="http://schemas.openxmlformats.org/drawingml/2006/main" r:embed="Rdbcf491706ac405a"/>
           <a:srcRect xmlns:a="http://schemas.openxmlformats.org/drawingml/2006/main" l="0" t="0" r="0" b="0"/>
           <a:stretch xmlns:a="http://schemas.openxmlformats.org/drawingml/2006/main">
             <a:fillRect l="0" t="0" r="0" b="0"/>
@@ -2931,7 +2931,7 @@
     </p:spTree>
     <p:extLst>
       <p:ext uri="{BB962C8B-B14F-4D97-AF65-F5344CB8AC3E}">
-        <p14:creationId xmlns:p14="http://schemas.microsoft.com/office/powerpoint/2010/main" val="342048982"/>
+        <p14:creationId xmlns:p14="http://schemas.microsoft.com/office/powerpoint/2010/main" val="2015592396"/>
       </p:ext>
     </p:extLst>
   </p:cSld>
@@ -2959,7 +2959,7 @@
           <p:nvPr/>
         </p:nvPicPr>
         <p:blipFill>
-          <a:blip xmlns:r="http://schemas.openxmlformats.org/officeDocument/2006/relationships" xmlns:a="http://schemas.openxmlformats.org/drawingml/2006/main" r:embed="R4ed5990a02444ffa"/>
+          <a:blip xmlns:r="http://schemas.openxmlformats.org/officeDocument/2006/relationships" xmlns:a="http://schemas.openxmlformats.org/drawingml/2006/main" r:embed="R217d8468b76c4c22"/>
           <a:srcRect xmlns:a="http://schemas.openxmlformats.org/drawingml/2006/main" l="0" t="0" r="0" b="0"/>
           <a:stretch xmlns:a="http://schemas.openxmlformats.org/drawingml/2006/main">
             <a:fillRect l="0" t="0" r="0" b="0"/>
@@ -2978,7 +2978,7 @@
     </p:spTree>
     <p:extLst>
       <p:ext uri="{BB962C8B-B14F-4D97-AF65-F5344CB8AC3E}">
-        <p14:creationId xmlns:p14="http://schemas.microsoft.com/office/powerpoint/2010/main" val="151985913"/>
+        <p14:creationId xmlns:p14="http://schemas.microsoft.com/office/powerpoint/2010/main" val="465410471"/>
       </p:ext>
     </p:extLst>
   </p:cSld>
@@ -3006,7 +3006,7 @@
           <p:nvPr/>
         </p:nvPicPr>
         <p:blipFill>
-          <a:blip xmlns:r="http://schemas.openxmlformats.org/officeDocument/2006/relationships" xmlns:a="http://schemas.openxmlformats.org/drawingml/2006/main" r:embed="R7bd2c8e342024595"/>
+          <a:blip xmlns:r="http://schemas.openxmlformats.org/officeDocument/2006/relationships" xmlns:a="http://schemas.openxmlformats.org/drawingml/2006/main" r:embed="R4ef9b90a90b4446f"/>
           <a:srcRect xmlns:a="http://schemas.openxmlformats.org/drawingml/2006/main" l="0" t="0" r="0" b="0"/>
           <a:stretch xmlns:a="http://schemas.openxmlformats.org/drawingml/2006/main">
             <a:fillRect l="0" t="0" r="0" b="0"/>
@@ -3025,7 +3025,7 @@
     </p:spTree>
     <p:extLst>
       <p:ext uri="{BB962C8B-B14F-4D97-AF65-F5344CB8AC3E}">
-        <p14:creationId xmlns:p14="http://schemas.microsoft.com/office/powerpoint/2010/main" val="2069365195"/>
+        <p14:creationId xmlns:p14="http://schemas.microsoft.com/office/powerpoint/2010/main" val="1522031217"/>
       </p:ext>
     </p:extLst>
   </p:cSld>
@@ -3053,7 +3053,7 @@
           <p:nvPr/>
         </p:nvPicPr>
         <p:blipFill>
-          <a:blip xmlns:r="http://schemas.openxmlformats.org/officeDocument/2006/relationships" xmlns:a="http://schemas.openxmlformats.org/drawingml/2006/main" r:embed="R0827dcb5137543b9"/>
+          <a:blip xmlns:r="http://schemas.openxmlformats.org/officeDocument/2006/relationships" xmlns:a="http://schemas.openxmlformats.org/drawingml/2006/main" r:embed="R99581593685144b9"/>
           <a:srcRect xmlns:a="http://schemas.openxmlformats.org/drawingml/2006/main" l="0" t="0" r="0" b="0"/>
           <a:stretch xmlns:a="http://schemas.openxmlformats.org/drawingml/2006/main">
             <a:fillRect l="0" t="0" r="0" b="0"/>
@@ -3072,7 +3072,7 @@
     </p:spTree>
     <p:extLst>
       <p:ext uri="{BB962C8B-B14F-4D97-AF65-F5344CB8AC3E}">
-        <p14:creationId xmlns:p14="http://schemas.microsoft.com/office/powerpoint/2010/main" val="194114547"/>
+        <p14:creationId xmlns:p14="http://schemas.microsoft.com/office/powerpoint/2010/main" val="512391358"/>
       </p:ext>
     </p:extLst>
   </p:cSld>
@@ -3100,7 +3100,7 @@
           <p:nvPr/>
         </p:nvPicPr>
         <p:blipFill>
-          <a:blip xmlns:r="http://schemas.openxmlformats.org/officeDocument/2006/relationships" xmlns:a="http://schemas.openxmlformats.org/drawingml/2006/main" r:embed="Re458e96967d947b1"/>
+          <a:blip xmlns:r="http://schemas.openxmlformats.org/officeDocument/2006/relationships" xmlns:a="http://schemas.openxmlformats.org/drawingml/2006/main" r:embed="Rdf85ce082fdd46a3"/>
           <a:srcRect xmlns:a="http://schemas.openxmlformats.org/drawingml/2006/main" l="0" t="0" r="0" b="0"/>
           <a:stretch xmlns:a="http://schemas.openxmlformats.org/drawingml/2006/main">
             <a:fillRect l="0" t="0" r="0" b="0"/>
@@ -3119,7 +3119,7 @@
     </p:spTree>
     <p:extLst>
       <p:ext uri="{BB962C8B-B14F-4D97-AF65-F5344CB8AC3E}">
-        <p14:creationId xmlns:p14="http://schemas.microsoft.com/office/powerpoint/2010/main" val="1216313586"/>
+        <p14:creationId xmlns:p14="http://schemas.microsoft.com/office/powerpoint/2010/main" val="975844903"/>
       </p:ext>
     </p:extLst>
   </p:cSld>
@@ -3147,7 +3147,7 @@
           <p:nvPr/>
         </p:nvPicPr>
         <p:blipFill>
-          <a:blip xmlns:r="http://schemas.openxmlformats.org/officeDocument/2006/relationships" xmlns:a="http://schemas.openxmlformats.org/drawingml/2006/main" r:embed="R5347c280b7ac40f5"/>
+          <a:blip xmlns:r="http://schemas.openxmlformats.org/officeDocument/2006/relationships" xmlns:a="http://schemas.openxmlformats.org/drawingml/2006/main" r:embed="R6eac91920017459b"/>
           <a:srcRect xmlns:a="http://schemas.openxmlformats.org/drawingml/2006/main" l="0" t="0" r="0" b="0"/>
           <a:stretch xmlns:a="http://schemas.openxmlformats.org/drawingml/2006/main">
             <a:fillRect l="0" t="0" r="0" b="0"/>
@@ -3166,7 +3166,7 @@
     </p:spTree>
     <p:extLst>
       <p:ext uri="{BB962C8B-B14F-4D97-AF65-F5344CB8AC3E}">
-        <p14:creationId xmlns:p14="http://schemas.microsoft.com/office/powerpoint/2010/main" val="231671545"/>
+        <p14:creationId xmlns:p14="http://schemas.microsoft.com/office/powerpoint/2010/main" val="1339813143"/>
       </p:ext>
     </p:extLst>
   </p:cSld>
@@ -3194,7 +3194,7 @@
           <p:nvPr/>
         </p:nvPicPr>
         <p:blipFill>
-          <a:blip xmlns:r="http://schemas.openxmlformats.org/officeDocument/2006/relationships" xmlns:a="http://schemas.openxmlformats.org/drawingml/2006/main" r:embed="R6de2faf5b4d34107"/>
+          <a:blip xmlns:r="http://schemas.openxmlformats.org/officeDocument/2006/relationships" xmlns:a="http://schemas.openxmlformats.org/drawingml/2006/main" r:embed="R01bdf297821843af"/>
           <a:srcRect xmlns:a="http://schemas.openxmlformats.org/drawingml/2006/main" l="0" t="0" r="0" b="0"/>
           <a:stretch xmlns:a="http://schemas.openxmlformats.org/drawingml/2006/main">
             <a:fillRect l="0" t="0" r="0" b="0"/>
@@ -3213,7 +3213,7 @@
     </p:spTree>
     <p:extLst>
       <p:ext uri="{BB962C8B-B14F-4D97-AF65-F5344CB8AC3E}">
-        <p14:creationId xmlns:p14="http://schemas.microsoft.com/office/powerpoint/2010/main" val="1649223367"/>
+        <p14:creationId xmlns:p14="http://schemas.microsoft.com/office/powerpoint/2010/main" val="1751274097"/>
       </p:ext>
     </p:extLst>
   </p:cSld>
@@ -3241,7 +3241,7 @@
           <p:nvPr/>
         </p:nvPicPr>
         <p:blipFill>
-          <a:blip xmlns:r="http://schemas.openxmlformats.org/officeDocument/2006/relationships" xmlns:a="http://schemas.openxmlformats.org/drawingml/2006/main" r:embed="Rcc0267f3317c478e"/>
+          <a:blip xmlns:r="http://schemas.openxmlformats.org/officeDocument/2006/relationships" xmlns:a="http://schemas.openxmlformats.org/drawingml/2006/main" r:embed="Rd12648eff68c43a8"/>
           <a:srcRect xmlns:a="http://schemas.openxmlformats.org/drawingml/2006/main" l="0" t="0" r="0" b="0"/>
           <a:stretch xmlns:a="http://schemas.openxmlformats.org/drawingml/2006/main">
             <a:fillRect l="0" t="0" r="0" b="0"/>
@@ -3260,7 +3260,7 @@
     </p:spTree>
     <p:extLst>
       <p:ext uri="{BB962C8B-B14F-4D97-AF65-F5344CB8AC3E}">
-        <p14:creationId xmlns:p14="http://schemas.microsoft.com/office/powerpoint/2010/main" val="987417375"/>
+        <p14:creationId xmlns:p14="http://schemas.microsoft.com/office/powerpoint/2010/main" val="621208972"/>
       </p:ext>
     </p:extLst>
   </p:cSld>
@@ -3288,7 +3288,7 @@
           <p:nvPr/>
         </p:nvPicPr>
         <p:blipFill>
-          <a:blip xmlns:r="http://schemas.openxmlformats.org/officeDocument/2006/relationships" xmlns:a="http://schemas.openxmlformats.org/drawingml/2006/main" r:embed="R5aa5918a880b4269"/>
+          <a:blip xmlns:r="http://schemas.openxmlformats.org/officeDocument/2006/relationships" xmlns:a="http://schemas.openxmlformats.org/drawingml/2006/main" r:embed="R1cc8b94264ee419f"/>
           <a:srcRect xmlns:a="http://schemas.openxmlformats.org/drawingml/2006/main" l="0" t="0" r="0" b="0"/>
           <a:stretch xmlns:a="http://schemas.openxmlformats.org/drawingml/2006/main">
             <a:fillRect l="0" t="0" r="0" b="0"/>
@@ -3307,7 +3307,7 @@
     </p:spTree>
     <p:extLst>
       <p:ext uri="{BB962C8B-B14F-4D97-AF65-F5344CB8AC3E}">
-        <p14:creationId xmlns:p14="http://schemas.microsoft.com/office/powerpoint/2010/main" val="1122311263"/>
+        <p14:creationId xmlns:p14="http://schemas.microsoft.com/office/powerpoint/2010/main" val="1034959428"/>
       </p:ext>
     </p:extLst>
   </p:cSld>
@@ -3335,7 +3335,7 @@
           <p:nvPr/>
         </p:nvPicPr>
         <p:blipFill>
-          <a:blip xmlns:r="http://schemas.openxmlformats.org/officeDocument/2006/relationships" xmlns:a="http://schemas.openxmlformats.org/drawingml/2006/main" r:embed="R73dd56146476473c"/>
+          <a:blip xmlns:r="http://schemas.openxmlformats.org/officeDocument/2006/relationships" xmlns:a="http://schemas.openxmlformats.org/drawingml/2006/main" r:embed="R2ef64da47d13469f"/>
           <a:srcRect xmlns:a="http://schemas.openxmlformats.org/drawingml/2006/main" l="0" t="0" r="0" b="0"/>
           <a:stretch xmlns:a="http://schemas.openxmlformats.org/drawingml/2006/main">
             <a:fillRect l="0" t="0" r="0" b="0"/>
@@ -3354,7 +3354,7 @@
     </p:spTree>
     <p:extLst>
       <p:ext uri="{BB962C8B-B14F-4D97-AF65-F5344CB8AC3E}">
-        <p14:creationId xmlns:p14="http://schemas.microsoft.com/office/powerpoint/2010/main" val="400809183"/>
+        <p14:creationId xmlns:p14="http://schemas.microsoft.com/office/powerpoint/2010/main" val="1243094692"/>
       </p:ext>
     </p:extLst>
   </p:cSld>
@@ -3382,7 +3382,7 @@
           <p:nvPr/>
         </p:nvPicPr>
         <p:blipFill>
-          <a:blip xmlns:r="http://schemas.openxmlformats.org/officeDocument/2006/relationships" xmlns:a="http://schemas.openxmlformats.org/drawingml/2006/main" r:embed="R20466ac1cb0c4172"/>
+          <a:blip xmlns:r="http://schemas.openxmlformats.org/officeDocument/2006/relationships" xmlns:a="http://schemas.openxmlformats.org/drawingml/2006/main" r:embed="Rc8e0029bdb0748a2"/>
           <a:srcRect xmlns:a="http://schemas.openxmlformats.org/drawingml/2006/main" l="0" t="0" r="0" b="0"/>
           <a:stretch xmlns:a="http://schemas.openxmlformats.org/drawingml/2006/main">
             <a:fillRect l="0" t="0" r="0" b="0"/>
@@ -3401,7 +3401,7 @@
     </p:spTree>
     <p:extLst>
       <p:ext uri="{BB962C8B-B14F-4D97-AF65-F5344CB8AC3E}">
-        <p14:creationId xmlns:p14="http://schemas.microsoft.com/office/powerpoint/2010/main" val="225287856"/>
+        <p14:creationId xmlns:p14="http://schemas.microsoft.com/office/powerpoint/2010/main" val="2010267136"/>
       </p:ext>
     </p:extLst>
   </p:cSld>
@@ -3429,7 +3429,7 @@
           <p:nvPr/>
         </p:nvPicPr>
         <p:blipFill>
-          <a:blip xmlns:r="http://schemas.openxmlformats.org/officeDocument/2006/relationships" xmlns:a="http://schemas.openxmlformats.org/drawingml/2006/main" r:embed="R228f132a0d0b4572"/>
+          <a:blip xmlns:r="http://schemas.openxmlformats.org/officeDocument/2006/relationships" xmlns:a="http://schemas.openxmlformats.org/drawingml/2006/main" r:embed="Rcd817108bd814c4f"/>
           <a:srcRect xmlns:a="http://schemas.openxmlformats.org/drawingml/2006/main" l="0" t="0" r="0" b="0"/>
           <a:stretch xmlns:a="http://schemas.openxmlformats.org/drawingml/2006/main">
             <a:fillRect l="0" t="0" r="0" b="0"/>
@@ -3448,7 +3448,7 @@
     </p:spTree>
     <p:extLst>
       <p:ext uri="{BB962C8B-B14F-4D97-AF65-F5344CB8AC3E}">
-        <p14:creationId xmlns:p14="http://schemas.microsoft.com/office/powerpoint/2010/main" val="181646624"/>
+        <p14:creationId xmlns:p14="http://schemas.microsoft.com/office/powerpoint/2010/main" val="1414193874"/>
       </p:ext>
     </p:extLst>
   </p:cSld>
@@ -3476,7 +3476,7 @@
           <p:nvPr/>
         </p:nvPicPr>
         <p:blipFill>
-          <a:blip xmlns:r="http://schemas.openxmlformats.org/officeDocument/2006/relationships" xmlns:a="http://schemas.openxmlformats.org/drawingml/2006/main" r:embed="R53e24ab173f644ff"/>
+          <a:blip xmlns:r="http://schemas.openxmlformats.org/officeDocument/2006/relationships" xmlns:a="http://schemas.openxmlformats.org/drawingml/2006/main" r:embed="Rb3b2bcc1ace049f1"/>
           <a:srcRect xmlns:a="http://schemas.openxmlformats.org/drawingml/2006/main" l="0" t="0" r="0" b="0"/>
           <a:stretch xmlns:a="http://schemas.openxmlformats.org/drawingml/2006/main">
             <a:fillRect l="0" t="0" r="0" b="0"/>
@@ -3495,7 +3495,7 @@
     </p:spTree>
     <p:extLst>
       <p:ext uri="{BB962C8B-B14F-4D97-AF65-F5344CB8AC3E}">
-        <p14:creationId xmlns:p14="http://schemas.microsoft.com/office/powerpoint/2010/main" val="193741592"/>
+        <p14:creationId xmlns:p14="http://schemas.microsoft.com/office/powerpoint/2010/main" val="268291672"/>
       </p:ext>
     </p:extLst>
   </p:cSld>
@@ -3523,7 +3523,7 @@
           <p:nvPr/>
         </p:nvPicPr>
         <p:blipFill>
-          <a:blip xmlns:r="http://schemas.openxmlformats.org/officeDocument/2006/relationships" xmlns:a="http://schemas.openxmlformats.org/drawingml/2006/main" r:embed="R7511ca79311f4e16"/>
+          <a:blip xmlns:r="http://schemas.openxmlformats.org/officeDocument/2006/relationships" xmlns:a="http://schemas.openxmlformats.org/drawingml/2006/main" r:embed="R093a26afe8904295"/>
           <a:srcRect xmlns:a="http://schemas.openxmlformats.org/drawingml/2006/main" l="0" t="0" r="0" b="0"/>
           <a:stretch xmlns:a="http://schemas.openxmlformats.org/drawingml/2006/main">
             <a:fillRect l="0" t="0" r="0" b="0"/>
@@ -3542,7 +3542,7 @@
     </p:spTree>
     <p:extLst>
       <p:ext uri="{BB962C8B-B14F-4D97-AF65-F5344CB8AC3E}">
-        <p14:creationId xmlns:p14="http://schemas.microsoft.com/office/powerpoint/2010/main" val="1842694872"/>
+        <p14:creationId xmlns:p14="http://schemas.microsoft.com/office/powerpoint/2010/main" val="258552745"/>
       </p:ext>
     </p:extLst>
   </p:cSld>

</xml_diff>